<commit_message>
tidying up user guid and making poster better
</commit_message>
<xml_diff>
--- a/Report/Apendix/Presentation Poster.pptx
+++ b/Report/Apendix/Presentation Poster.pptx
@@ -15398,7 +15398,7 @@
             <a:fld id="{B61BEF0D-F0BB-DE4B-95CE-6DB70DBA9567}" type="datetimeFigureOut">
               <a:rPr lang="en-US" smtClean="0"/>
               <a:pPr/>
-              <a:t>4/27/2026</a:t>
+              <a:t>4/27/26</a:t>
             </a:fld>
             <a:endParaRPr lang="en-US" dirty="0"/>
           </a:p>
@@ -16837,8 +16837,8 @@
         </p:nvSpPr>
         <p:spPr bwMode="auto">
           <a:xfrm>
-            <a:off x="32219087" y="27522982"/>
-            <a:ext cx="10008000" cy="2322018"/>
+            <a:off x="32219087" y="26730894"/>
+            <a:ext cx="10008000" cy="3132842"/>
           </a:xfrm>
           <a:prstGeom prst="rect">
             <a:avLst/>
@@ -16963,58 +16963,113 @@
             </a:lvl9pPr>
           </a:lstStyle>
           <a:p>
-            <a:pPr>
-              <a:spcBef>
-                <a:spcPct val="40000"/>
-              </a:spcBef>
-            </a:pPr>
             <a:r>
-              <a:rPr lang="en-AU" altLang="en-US" sz="3200" b="1" dirty="0">
-                <a:solidFill>
-                  <a:srgbClr val="464646"/>
-                </a:solidFill>
-                <a:latin typeface="Calibri" charset="0"/>
-                <a:ea typeface="Calibri" charset="0"/>
-                <a:cs typeface="Calibri" charset="0"/>
-              </a:rPr>
-              <a:t>Body text: </a:t>
-            </a:r>
-            <a:r>
-              <a:rPr lang="en-AU" altLang="en-US" sz="3200" dirty="0">
-                <a:solidFill>
-                  <a:srgbClr val="464646"/>
-                </a:solidFill>
-                <a:latin typeface="Calibri" charset="0"/>
-                <a:ea typeface="Calibri" charset="0"/>
-                <a:cs typeface="Calibri" charset="0"/>
-              </a:rPr>
-              <a:t>Calibri 32pt minimum.</a:t>
+              <a:rPr lang="en-GB" sz="1400" dirty="0"/>
+              <a:t>[12]</a:t>
             </a:r>
           </a:p>
           <a:p>
-            <a:pPr>
-              <a:spcBef>
-                <a:spcPct val="40000"/>
-              </a:spcBef>
-            </a:pPr>
             <a:r>
-              <a:rPr lang="en-US" altLang="en-US" sz="3200" dirty="0">
-                <a:solidFill>
-                  <a:srgbClr val="464646"/>
-                </a:solidFill>
-                <a:latin typeface="Calibri" charset="0"/>
-                <a:ea typeface="Calibri" charset="0"/>
-                <a:cs typeface="Calibri" charset="0"/>
-              </a:rPr>
-              <a:t>Avoid drop shadows, outlines and other text effects.</a:t>
+              <a:rPr lang="en-GB" sz="1400" dirty="0"/>
+              <a:t>R. </a:t>
             </a:r>
-            <a:endParaRPr lang="en-AU" altLang="en-US" sz="3200" dirty="0">
-              <a:solidFill>
-                <a:srgbClr val="464646"/>
-              </a:solidFill>
-              <a:latin typeface="Calibri" charset="0"/>
+            <a:r>
+              <a:rPr lang="en-GB" sz="1400" dirty="0" err="1"/>
+              <a:t>Alrawili</a:t>
+            </a:r>
+            <a:r>
+              <a:rPr lang="en-GB" sz="1400" dirty="0"/>
+              <a:t>, A. A. S. AlQahtani, and M. K. Khan, “Comprehensive survey: Biometric user authentication application, evaluation, and discussion,” </a:t>
+            </a:r>
+            <a:r>
+              <a:rPr lang="en-GB" sz="1400" i="1" dirty="0"/>
+              <a:t>Computers and Electrical Engineering</a:t>
+            </a:r>
+            <a:r>
+              <a:rPr lang="en-GB" sz="1400" dirty="0"/>
+              <a:t>, vol. 119, no. A, p. 109485, Oct. 2024, </a:t>
+            </a:r>
+            <a:r>
+              <a:rPr lang="en-GB" sz="1400" dirty="0" err="1"/>
+              <a:t>doi</a:t>
+            </a:r>
+            <a:r>
+              <a:rPr lang="en-GB" sz="1400" dirty="0"/>
+              <a:t>: </a:t>
+            </a:r>
+          </a:p>
+          <a:p>
+            <a:r>
+              <a:rPr lang="en-GB" sz="1400" dirty="0"/>
+              <a:t>[19]</a:t>
+            </a:r>
+          </a:p>
+          <a:p>
+            <a:r>
+              <a:rPr lang="en-GB" sz="1400" dirty="0"/>
+              <a:t>A. Devasia, “Biometric Access Control System Price: Full Guide (2024),” </a:t>
+            </a:r>
+            <a:r>
+              <a:rPr lang="en-GB" sz="1400" i="1" dirty="0"/>
+              <a:t>Safe and Sound Security</a:t>
+            </a:r>
+            <a:r>
+              <a:rPr lang="en-GB" sz="1400" dirty="0"/>
+              <a:t>, May 29, 2024. https://</a:t>
+            </a:r>
+            <a:r>
+              <a:rPr lang="en-GB" sz="1400" dirty="0" err="1"/>
+              <a:t>getsafeandsound.com</a:t>
+            </a:r>
+            <a:r>
+              <a:rPr lang="en-GB" sz="1400" dirty="0"/>
+              <a:t>/blog/biometric-access-control-system-price/</a:t>
+            </a:r>
+          </a:p>
+          <a:p>
+            <a:r>
+              <a:rPr lang="en-GB" sz="1400" dirty="0"/>
+              <a:t>[7]</a:t>
+            </a:r>
+          </a:p>
+          <a:p>
+            <a:r>
+              <a:rPr lang="en-GB" sz="1400" dirty="0"/>
+              <a:t>E. Hill, M. Sobolewska, S. Wilks-Heeg, and M. Borkowska, “Explaining electoral fraud in an advanced democracy: Fraud vulnerabilities, opportunities and facilitating mechanisms in British elections,” </a:t>
+            </a:r>
+            <a:r>
+              <a:rPr lang="en-GB" sz="1400" i="1" dirty="0"/>
+              <a:t>The British Journal of Politics and International Relations</a:t>
+            </a:r>
+            <a:r>
+              <a:rPr lang="en-GB" sz="1400" dirty="0"/>
+              <a:t>, vol. 19, no. 4, pp. 772–789, Jun. 2017, </a:t>
+            </a:r>
+            <a:r>
+              <a:rPr lang="en-GB" sz="1400" dirty="0" err="1"/>
+              <a:t>doi</a:t>
+            </a:r>
+            <a:r>
+              <a:rPr lang="en-GB" sz="1400" dirty="0"/>
+              <a:t>: https://</a:t>
+            </a:r>
+            <a:r>
+              <a:rPr lang="en-GB" sz="1400" dirty="0" err="1"/>
+              <a:t>doi.org</a:t>
+            </a:r>
+            <a:r>
+              <a:rPr lang="en-GB" sz="1400" dirty="0"/>
+              <a:t>/10.1177/1369148117715222.</a:t>
+            </a:r>
+          </a:p>
+          <a:p>
+            <a:endParaRPr lang="en-GB" sz="1400" dirty="0"/>
+          </a:p>
+          <a:p>
+            <a:endParaRPr lang="en-AU" altLang="en-US" sz="1600" dirty="0">
+              <a:latin typeface="Calibri" panose="020F0502020204030204" pitchFamily="34" charset="0"/>
               <a:ea typeface="Calibri" charset="0"/>
-              <a:cs typeface="Calibri" charset="0"/>
+              <a:cs typeface="Calibri" panose="020F0502020204030204" pitchFamily="34" charset="0"/>
             </a:endParaRPr>
           </a:p>
         </p:txBody>
@@ -17029,7 +17084,7 @@
         </p:nvSpPr>
         <p:spPr bwMode="auto">
           <a:xfrm>
-            <a:off x="32219087" y="26082982"/>
+            <a:off x="32219086" y="25761446"/>
             <a:ext cx="10008000" cy="1440000"/>
           </a:xfrm>
           <a:prstGeom prst="rect">
@@ -17064,7 +17119,7 @@
                 <a:ea typeface="Calibri" charset="0"/>
                 <a:cs typeface="Calibri" charset="0"/>
               </a:rPr>
-              <a:t>Acknowledgements</a:t>
+              <a:t>References</a:t>
             </a:r>
           </a:p>
         </p:txBody>
@@ -17530,7 +17585,7 @@
                 <a:latin typeface="Calibri" panose="020F0502020204030204" pitchFamily="34" charset="0"/>
                 <a:cs typeface="Calibri" panose="020F0502020204030204" pitchFamily="34" charset="0"/>
               </a:rPr>
-              <a:t>Channels scoped by county and constituency </a:t>
+              <a:t>Channels used to organise connections are categorised by county and constituency </a:t>
             </a:r>
           </a:p>
           <a:p>
@@ -17543,7 +17598,7 @@
                 <a:latin typeface="Calibri" panose="020F0502020204030204" pitchFamily="34" charset="0"/>
                 <a:cs typeface="Calibri" panose="020F0502020204030204" pitchFamily="34" charset="0"/>
               </a:rPr>
-              <a:t>Sever EC2 instance is the only IP the database is permitted to communicate </a:t>
+              <a:t>Sever EC2 instance is the only IP the database is permitted to communicate with </a:t>
             </a:r>
           </a:p>
           <a:p>
@@ -17556,7 +17611,7 @@
                 <a:latin typeface="Calibri" panose="020F0502020204030204" pitchFamily="34" charset="0"/>
                 <a:cs typeface="Calibri" panose="020F0502020204030204" pitchFamily="34" charset="0"/>
               </a:rPr>
-              <a:t>Creates JWT tokens that live for 8 hours which is the expected polling station opening times</a:t>
+              <a:t>Voter device JWT tokens issued live for 8 hours which is the expected polling station opening times</a:t>
             </a:r>
           </a:p>
           <a:p>
@@ -17615,7 +17670,7 @@
                 <a:latin typeface="Calibri" panose="020F0502020204030204" pitchFamily="34" charset="0"/>
                 <a:cs typeface="Calibri" panose="020F0502020204030204" pitchFamily="34" charset="0"/>
               </a:rPr>
-              <a:t>Cross platform desktop apps built in Avalonia UI, running on Windows and macOS</a:t>
+              <a:t>Apps were built using Avalonia which allows the system to run on Windows and macOS </a:t>
             </a:r>
           </a:p>
           <a:p>
@@ -17628,7 +17683,7 @@
                 <a:latin typeface="Calibri" panose="020F0502020204030204" pitchFamily="34" charset="0"/>
                 <a:cs typeface="Calibri" panose="020F0502020204030204" pitchFamily="34" charset="0"/>
               </a:rPr>
-              <a:t>MVVM architecture for clean separated logic between User Interface and logic </a:t>
+              <a:t>MVVM architecture used for clean separated logic between User Interface and backend logic </a:t>
             </a:r>
           </a:p>
           <a:p>
@@ -17666,49 +17721,6 @@
               <a:latin typeface="Calibri" panose="020F0502020204030204" pitchFamily="34" charset="0"/>
               <a:cs typeface="Calibri" panose="020F0502020204030204" pitchFamily="34" charset="0"/>
             </a:endParaRPr>
-          </a:p>
-          <a:p>
-            <a:pPr marL="571500" indent="-571500">
-              <a:buFont typeface="Arial" panose="020B0604020202020204" pitchFamily="34" charset="0"/>
-              <a:buChar char="•"/>
-            </a:pPr>
-            <a:endParaRPr lang="en-GB" sz="3600" dirty="0">
-              <a:latin typeface="Calibri" panose="020F0502020204030204" pitchFamily="34" charset="0"/>
-              <a:cs typeface="Calibri" panose="020F0502020204030204" pitchFamily="34" charset="0"/>
-            </a:endParaRPr>
-          </a:p>
-          <a:p>
-            <a:pPr marL="571500" indent="-571500">
-              <a:buFont typeface="Arial" panose="020B0604020202020204" pitchFamily="34" charset="0"/>
-              <a:buChar char="•"/>
-            </a:pPr>
-            <a:endParaRPr lang="en-GB" sz="3600" dirty="0">
-              <a:latin typeface="Calibri" panose="020F0502020204030204" pitchFamily="34" charset="0"/>
-              <a:cs typeface="Calibri" panose="020F0502020204030204" pitchFamily="34" charset="0"/>
-            </a:endParaRPr>
-          </a:p>
-          <a:p>
-            <a:pPr marL="571500" indent="-571500">
-              <a:buFont typeface="Arial" panose="020B0604020202020204" pitchFamily="34" charset="0"/>
-              <a:buChar char="•"/>
-            </a:pPr>
-            <a:endParaRPr lang="en-GB" sz="3600" dirty="0">
-              <a:latin typeface="Calibri" panose="020F0502020204030204" pitchFamily="34" charset="0"/>
-              <a:cs typeface="Calibri" panose="020F0502020204030204" pitchFamily="34" charset="0"/>
-            </a:endParaRPr>
-          </a:p>
-          <a:p>
-            <a:pPr marL="571500" indent="-571500">
-              <a:buFont typeface="Arial" panose="020B0604020202020204" pitchFamily="34" charset="0"/>
-              <a:buChar char="•"/>
-            </a:pPr>
-            <a:r>
-              <a:rPr lang="en-GB" sz="3600" dirty="0">
-                <a:latin typeface="Calibri" panose="020F0502020204030204" pitchFamily="34" charset="0"/>
-                <a:cs typeface="Calibri" panose="020F0502020204030204" pitchFamily="34" charset="0"/>
-              </a:rPr>
-              <a:t>NOT FINISHED CHUMP</a:t>
-            </a:r>
           </a:p>
         </p:txBody>
       </p:sp>
@@ -17946,7 +17958,7 @@
                 <a:latin typeface="Calibri" panose="020F0502020204030204" pitchFamily="34" charset="0"/>
                 <a:cs typeface="Calibri" panose="020F0502020204030204" pitchFamily="34" charset="0"/>
               </a:rPr>
-              <a:t> was absorbed mid-project without significant disruption to the broader timeline.</a:t>
+              <a:t> was absorbed mid project without significant disruption to the broader timeline.</a:t>
             </a:r>
           </a:p>
           <a:p>
@@ -17974,7 +17986,7 @@
                 <a:latin typeface="Calibri" panose="020F0502020204030204" pitchFamily="34" charset="0"/>
                 <a:cs typeface="Calibri" panose="020F0502020204030204" pitchFamily="34" charset="0"/>
               </a:rPr>
-              <a:t>The system successfully delivers fingerprint authenticated voting with structural ballot anonymity. Both rounds of user evaluation confirmed the voting process is intuitive, and the Official App improved significantly following the redesign. Key limitations remain around GDPR compliant data retention, macOS scanner compatibility, and server scalability beyond 1,000 concurrent connections.</a:t>
+              <a:t>The system successfully delivers a fingerprint authenticated voting system with structural ballot anonymity. Both rounds of user evaluation confirmed the voting process is intuitive, and the Official App improved significantly following the redesign. Key limitations remain around GDPR compliant data retention, macOS scanner compatibility, and server scalability beyond 1,000 concurrent connections.</a:t>
             </a:r>
           </a:p>
           <a:p>
@@ -18002,7 +18014,35 @@
                 <a:latin typeface="Calibri" panose="020F0502020204030204" pitchFamily="34" charset="0"/>
                 <a:cs typeface="Calibri" panose="020F0502020204030204" pitchFamily="34" charset="0"/>
               </a:rPr>
-              <a:t>This project successfully demonstrated that a fingerprint authenticated E-voting system can address the structural weaknesses of the UK's paper based voting process. Ballot anonymity is enforced by design, voter identity is verified without forgeable identifiers, and results are produced instantly. While accessibility, scalability, and GDPR-compliant data retention require further development, the system presents a credible and secure foundation for biometric e-voting in the UK.</a:t>
+              <a:t>This project successfully demonstrated that a fingerprint authenticated E-voting system can address the structural weaknesses of the UK's paper based voting process. Ballot anonymity is enforced by design, voter identity is verified without forgeable identifiers, and results are produced instantly. While accessibility, scalability, </a:t>
+            </a:r>
+            <a:r>
+              <a:rPr lang="en-GB" sz="3200">
+                <a:latin typeface="Calibri" panose="020F0502020204030204" pitchFamily="34" charset="0"/>
+                <a:cs typeface="Calibri" panose="020F0502020204030204" pitchFamily="34" charset="0"/>
+              </a:rPr>
+              <a:t>and GDPR compliant </a:t>
+            </a:r>
+            <a:r>
+              <a:rPr lang="en-GB" sz="3200" dirty="0">
+                <a:latin typeface="Calibri" panose="020F0502020204030204" pitchFamily="34" charset="0"/>
+                <a:cs typeface="Calibri" panose="020F0502020204030204" pitchFamily="34" charset="0"/>
+              </a:rPr>
+              <a:t>data retention require further development, the system presents a credible and secure foundation for </a:t>
+            </a:r>
+            <a:r>
+              <a:rPr lang="en-GB" sz="3200">
+                <a:latin typeface="Calibri" panose="020F0502020204030204" pitchFamily="34" charset="0"/>
+                <a:cs typeface="Calibri" panose="020F0502020204030204" pitchFamily="34" charset="0"/>
+              </a:rPr>
+              <a:t>biometric E-voting </a:t>
+            </a:r>
+            <a:r>
+              <a:rPr lang="en-GB" sz="3200" dirty="0">
+                <a:latin typeface="Calibri" panose="020F0502020204030204" pitchFamily="34" charset="0"/>
+                <a:cs typeface="Calibri" panose="020F0502020204030204" pitchFamily="34" charset="0"/>
+              </a:rPr>
+              <a:t>in the UK.</a:t>
             </a:r>
           </a:p>
           <a:p>
@@ -18082,8 +18122,8 @@
         </p:nvSpPr>
         <p:spPr bwMode="auto">
           <a:xfrm>
-            <a:off x="575087" y="9333393"/>
-            <a:ext cx="10008000" cy="10124693"/>
+            <a:off x="574938" y="9084638"/>
+            <a:ext cx="10008000" cy="10268709"/>
           </a:xfrm>
           <a:prstGeom prst="rect">
             <a:avLst/>
@@ -18233,7 +18273,7 @@
                 <a:latin typeface="Calibri" panose="020F0502020204030204" pitchFamily="34" charset="0"/>
                 <a:cs typeface="Calibri" panose="020F0502020204030204" pitchFamily="34" charset="0"/>
               </a:rPr>
-              <a:t>The UK Voting System still relies on paper ballots and manual counting, a system largely unchanged since 1888. This introduces several well-documented vulnerabilities:</a:t>
+              <a:t>The UK Voting System still relies on paper ballots and manual counting, a system largely unchanged since 1888 [7]. This introduces several well-documented vulnerabilities:</a:t>
             </a:r>
           </a:p>
           <a:p>
@@ -18245,7 +18285,10 @@
               <a:buChar char="•"/>
             </a:pPr>
             <a:r>
-              <a:rPr lang="en-GB" sz="3600" dirty="0"/>
+              <a:rPr lang="en-GB" sz="3600" dirty="0">
+                <a:latin typeface="Calibri" panose="020F0502020204030204" pitchFamily="34" charset="0"/>
+                <a:cs typeface="Calibri" panose="020F0502020204030204" pitchFamily="34" charset="0"/>
+              </a:rPr>
               <a:t>Voter impersonation is difficult to detect under the current name, address, and signature model</a:t>
             </a:r>
           </a:p>
@@ -18258,7 +18301,10 @@
               <a:buChar char="•"/>
             </a:pPr>
             <a:r>
-              <a:rPr lang="en-GB" sz="3600" dirty="0"/>
+              <a:rPr lang="en-GB" sz="3600" dirty="0">
+                <a:latin typeface="Calibri" panose="020F0502020204030204" pitchFamily="34" charset="0"/>
+                <a:cs typeface="Calibri" panose="020F0502020204030204" pitchFamily="34" charset="0"/>
+              </a:rPr>
               <a:t>Ballot tampering risk arises from physical handling during transportation and counting</a:t>
             </a:r>
           </a:p>
@@ -18271,7 +18317,10 @@
               <a:buChar char="•"/>
             </a:pPr>
             <a:r>
-              <a:rPr lang="en-GB" sz="3600" dirty="0"/>
+              <a:rPr lang="en-GB" sz="3600" dirty="0">
+                <a:latin typeface="Calibri" panose="020F0502020204030204" pitchFamily="34" charset="0"/>
+                <a:cs typeface="Calibri" panose="020F0502020204030204" pitchFamily="34" charset="0"/>
+              </a:rPr>
               <a:t>Manual counting is slow and costly</a:t>
             </a:r>
           </a:p>
@@ -18284,7 +18333,10 @@
               <a:buChar char="•"/>
             </a:pPr>
             <a:r>
-              <a:rPr lang="en-GB" sz="3600" dirty="0"/>
+              <a:rPr lang="en-GB" sz="3600" dirty="0">
+                <a:latin typeface="Calibri" panose="020F0502020204030204" pitchFamily="34" charset="0"/>
+                <a:cs typeface="Calibri" panose="020F0502020204030204" pitchFamily="34" charset="0"/>
+              </a:rPr>
               <a:t>Postal voting carries documented risks of undue influence, language barriers, and misrepresentation</a:t>
             </a:r>
           </a:p>
@@ -18617,8 +18669,8 @@
         </p:nvSpPr>
         <p:spPr>
           <a:xfrm>
-            <a:off x="1481720" y="4984057"/>
-            <a:ext cx="27337406" cy="1969770"/>
+            <a:off x="556461" y="4499989"/>
+            <a:ext cx="41670625" cy="2539157"/>
           </a:xfrm>
           <a:prstGeom prst="rect">
             <a:avLst/>
@@ -18631,13 +18683,13 @@
           </a:bodyPr>
           <a:lstStyle/>
           <a:p>
-            <a:pPr fontAlgn="t">
+            <a:pPr algn="ctr" fontAlgn="t">
               <a:spcAft>
                 <a:spcPts val="1200"/>
               </a:spcAft>
             </a:pPr>
             <a:r>
-              <a:rPr lang="en-GB" sz="8200" b="1" dirty="0">
+              <a:rPr lang="en-GB" sz="11500" b="1" dirty="0">
                 <a:solidFill>
                   <a:srgbClr val="4365E2"/>
                 </a:solidFill>
@@ -18647,19 +18699,19 @@
               </a:rPr>
               <a:t>Fingerprint Authenticated E-Voting System </a:t>
             </a:r>
-            <a:endParaRPr lang="en-GB" b="1" dirty="0">
+            <a:endParaRPr lang="en-GB" sz="2800" b="1" dirty="0">
               <a:latin typeface="Calibri" panose="020F0502020204030204" pitchFamily="34" charset="0"/>
               <a:cs typeface="Calibri" panose="020F0502020204030204" pitchFamily="34" charset="0"/>
             </a:endParaRPr>
           </a:p>
           <a:p>
-            <a:pPr fontAlgn="t">
+            <a:pPr algn="ctr" fontAlgn="t">
               <a:spcAft>
                 <a:spcPts val="1200"/>
               </a:spcAft>
             </a:pPr>
             <a:r>
-              <a:rPr lang="en-GB" sz="3600" dirty="0">
+              <a:rPr lang="en-GB" sz="4000" dirty="0">
                 <a:solidFill>
                   <a:srgbClr val="4365E2"/>
                 </a:solidFill>
@@ -19065,7 +19117,7 @@
                 <a:latin typeface="Calibri" panose="020F0502020204030204" pitchFamily="34" charset="0"/>
                 <a:cs typeface="Calibri" panose="020F0502020204030204" pitchFamily="34" charset="0"/>
               </a:rPr>
-              <a:t>Real-world viability evidenced by Brazil's national deployment</a:t>
+              <a:t>Real world viability shown by Brazil's national deployment</a:t>
             </a:r>
           </a:p>
           <a:p>
@@ -19146,7 +19198,7 @@
                 <a:latin typeface="Calibri" panose="020F0502020204030204" pitchFamily="34" charset="0"/>
                 <a:cs typeface="Calibri" panose="020F0502020204030204" pitchFamily="34" charset="0"/>
               </a:rPr>
-              <a:t>Table Of Scanner cost and False acceptance Rate </a:t>
+              <a:t>Table Of Scanner cost and False acceptance Rate [12][19]</a:t>
             </a:r>
           </a:p>
         </p:txBody>
@@ -19167,8 +19219,8 @@
         </p:nvSpPr>
         <p:spPr bwMode="auto">
           <a:xfrm>
-            <a:off x="572833" y="21398840"/>
-            <a:ext cx="10008000" cy="8464896"/>
+            <a:off x="574154" y="20743920"/>
+            <a:ext cx="10008000" cy="9119816"/>
           </a:xfrm>
           <a:prstGeom prst="rect">
             <a:avLst/>
@@ -19334,7 +19386,7 @@
                 <a:latin typeface="Calibri" panose="020F0502020204030204" pitchFamily="34" charset="0"/>
                 <a:cs typeface="Calibri" panose="020F0502020204030204" pitchFamily="34" charset="0"/>
               </a:rPr>
-              <a:t> was validated against two open source datasets. Firstly FVC2002, providing clean fingerprint scans to benchmark performance under ideal conditions, and </a:t>
+              <a:t> was tested against two open source datasets. Firstly FVC2002, providing clean fingerprint scans to benchmark performance under ideal conditions, and </a:t>
             </a:r>
             <a:r>
               <a:rPr lang="en-GB" sz="3200" dirty="0" err="1">
@@ -19348,7 +19400,21 @@
                 <a:latin typeface="Calibri" panose="020F0502020204030204" pitchFamily="34" charset="0"/>
                 <a:cs typeface="Calibri" panose="020F0502020204030204" pitchFamily="34" charset="0"/>
               </a:rPr>
-              <a:t>, containing deliberately damaged fingerprints to challenge the system's ability to reject false positive matches.</a:t>
+              <a:t>, containing deliberately damaged fingerprints to challenge the system's ability to reject false positive matches. The Test showed that </a:t>
+            </a:r>
+            <a:r>
+              <a:rPr lang="en-GB" sz="3200" dirty="0" err="1">
+                <a:latin typeface="Calibri" panose="020F0502020204030204" pitchFamily="34" charset="0"/>
+                <a:cs typeface="Calibri" panose="020F0502020204030204" pitchFamily="34" charset="0"/>
+              </a:rPr>
+              <a:t>SourceAFIS</a:t>
+            </a:r>
+            <a:r>
+              <a:rPr lang="en-GB" sz="3200" dirty="0">
+                <a:latin typeface="Calibri" panose="020F0502020204030204" pitchFamily="34" charset="0"/>
+                <a:cs typeface="Calibri" panose="020F0502020204030204" pitchFamily="34" charset="0"/>
+              </a:rPr>
+              <a:t> had a False Acceptance Rate of 0 for both databases, showing that it is a secure software to use in a voting system as it rejects all false matches. </a:t>
             </a:r>
           </a:p>
           <a:p>
@@ -19376,7 +19442,7 @@
                 <a:latin typeface="Calibri" panose="020F0502020204030204" pitchFamily="34" charset="0"/>
                 <a:cs typeface="Calibri" panose="020F0502020204030204" pitchFamily="34" charset="0"/>
               </a:rPr>
-              <a:t>A concurrent connection load test was conducted against the live EC2 hosted server, ramping connections across five levels from 100 to 2,000. The server sustained up to 964 simultaneous connections reliably, with failures increasing significantly beyond. </a:t>
+              <a:t>A concurrent connection load test was conducted against the live EC2 hosted server, increasing connections across five levels from 100 to 2,000. The server handled up to 964 simultaneous connections reliably, with failures increasing significantly beyond. </a:t>
             </a:r>
             <a:endParaRPr lang="en-AU" altLang="en-US" sz="3200" dirty="0">
               <a:latin typeface="Calibri" panose="020F0502020204030204" pitchFamily="34" charset="0"/>
@@ -19401,7 +19467,7 @@
         </p:nvSpPr>
         <p:spPr bwMode="auto">
           <a:xfrm>
-            <a:off x="572833" y="19958840"/>
+            <a:off x="572833" y="19698100"/>
             <a:ext cx="10008000" cy="1440000"/>
           </a:xfrm>
           <a:prstGeom prst="rect">
@@ -20005,9 +20071,12 @@
 </file>
 
 <file path=customXml/item1.xml><?xml version="1.0" encoding="utf-8"?>
-<p:properties xmlns:p="http://schemas.microsoft.com/office/2006/metadata/properties" xmlns:xsi="http://www.w3.org/2001/XMLSchema-instance" xmlns:pc="http://schemas.microsoft.com/office/infopath/2007/PartnerControls">
-  <documentManagement/>
-</p:properties>
+<?mso-contentType ?>
+<FormTemplates xmlns="http://schemas.microsoft.com/sharepoint/v3/contenttype/forms">
+  <Display>DocumentLibraryForm</Display>
+  <Edit>DocumentLibraryForm</Edit>
+  <New>DocumentLibraryForm</New>
+</FormTemplates>
 </file>
 
 <file path=customXml/item2.xml><?xml version="1.0" encoding="utf-8"?>
@@ -20240,19 +20309,15 @@
 </file>
 
 <file path=customXml/item3.xml><?xml version="1.0" encoding="utf-8"?>
-<?mso-contentType ?>
-<FormTemplates xmlns="http://schemas.microsoft.com/sharepoint/v3/contenttype/forms">
-  <Display>DocumentLibraryForm</Display>
-  <Edit>DocumentLibraryForm</Edit>
-  <New>DocumentLibraryForm</New>
-</FormTemplates>
+<p:properties xmlns:p="http://schemas.microsoft.com/office/2006/metadata/properties" xmlns:xsi="http://www.w3.org/2001/XMLSchema-instance" xmlns:pc="http://schemas.microsoft.com/office/infopath/2007/PartnerControls">
+  <documentManagement/>
+</p:properties>
 </file>
 
 <file path=customXml/itemProps1.xml><?xml version="1.0" encoding="utf-8"?>
-<ds:datastoreItem xmlns:ds="http://schemas.openxmlformats.org/officeDocument/2006/customXml" ds:itemID="{E84CD8CF-1E7F-4189-A2CF-F0D242259026}">
+<ds:datastoreItem xmlns:ds="http://schemas.openxmlformats.org/officeDocument/2006/customXml" ds:itemID="{65D0E912-FAE1-480B-B795-CE11C37D717D}">
   <ds:schemaRefs>
-    <ds:schemaRef ds:uri="http://schemas.microsoft.com/office/2006/metadata/properties"/>
-    <ds:schemaRef ds:uri="http://schemas.microsoft.com/office/infopath/2007/PartnerControls"/>
+    <ds:schemaRef ds:uri="http://schemas.microsoft.com/sharepoint/v3/contenttype/forms"/>
   </ds:schemaRefs>
 </ds:datastoreItem>
 </file>
@@ -20277,9 +20342,10 @@
 </file>
 
 <file path=customXml/itemProps3.xml><?xml version="1.0" encoding="utf-8"?>
-<ds:datastoreItem xmlns:ds="http://schemas.openxmlformats.org/officeDocument/2006/customXml" ds:itemID="{65D0E912-FAE1-480B-B795-CE11C37D717D}">
+<ds:datastoreItem xmlns:ds="http://schemas.openxmlformats.org/officeDocument/2006/customXml" ds:itemID="{E84CD8CF-1E7F-4189-A2CF-F0D242259026}">
   <ds:schemaRefs>
-    <ds:schemaRef ds:uri="http://schemas.microsoft.com/sharepoint/v3/contenttype/forms"/>
+    <ds:schemaRef ds:uri="http://schemas.microsoft.com/office/2006/metadata/properties"/>
+    <ds:schemaRef ds:uri="http://schemas.microsoft.com/office/infopath/2007/PartnerControls"/>
   </ds:schemaRefs>
 </ds:datastoreItem>
 </file>
</xml_diff>